<commit_message>
QA loop closed: renderer fixes (cover contrast, HUD pill, card anatomy, flow arrows, hashchange nav), final demo artifacts, QA report
</commit_message>
<xml_diff>
--- a/examples/pitchcraft-demo/output/deck.pptx
+++ b/examples/pitchcraft-demo/output/deck.pptx
@@ -2525,45 +2525,6 @@
         </p:nvSpPr>
         <p:spPr>
           <a:xfrm>
-            <a:off x="548640" y="6510528"/>
-            <a:ext cx="11091672" cy="228600"/>
-          </a:xfrm>
-          <a:prstGeom prst="rect">
-            <a:avLst/>
-          </a:prstGeom>
-          <a:noFill/>
-          <a:ln/>
-        </p:spPr>
-        <p:txBody>
-          <a:bodyPr wrap="square" rtlCol="0" anchor="ctr"/>
-          <a:lstStyle/>
-          <a:p>
-            <a:pPr indent="0" marL="0">
-              <a:buNone/>
-            </a:pPr>
-            <a:r>
-              <a:rPr lang="en-US" sz="800" i="1" dirty="0">
-                <a:solidFill>
-                  <a:srgbClr val="6B645B"/>
-                </a:solidFill>
-                <a:latin typeface="Verdana" pitchFamily="34" charset="0"/>
-                <a:ea typeface="Verdana" pitchFamily="34" charset="-122"/>
-                <a:cs typeface="Verdana" pitchFamily="34" charset="-120"/>
-              </a:rPr>
-              <a:t>Sources: spec Final Mandate</a:t>
-            </a:r>
-            <a:endParaRPr lang="en-US" sz="800" dirty="0"/>
-          </a:p>
-        </p:txBody>
-      </p:sp>
-      <p:sp>
-        <p:nvSpPr>
-          <p:cNvPr id="5" name="Text 3"/>
-          <p:cNvSpPr/>
-          <p:nvPr/>
-        </p:nvSpPr>
-        <p:spPr>
-          <a:xfrm>
             <a:off x="11292840" y="6492240"/>
             <a:ext cx="548640" cy="274320"/>
           </a:xfrm>

</xml_diff>